<commit_message>
Align lifecycle requirements in review template
Signed-off-by: John Mertic <jmertic@linuxfoundation.org>
</commit_message>
<xml_diff>
--- a/process/annual_review_template.pptx
+++ b/process/annual_review_template.pptx
@@ -20279,206 +20279,190 @@
               <a:buNone/>
             </a:pPr>
             <a:r>
-              <a:rPr lang="en-US" sz="1800"/>
+              <a:rPr lang="en-US" sz="2100"/>
               <a:t>To be considered for the Incubation Stage, the project must meet the following requirements:</a:t>
             </a:r>
-            <a:endParaRPr sz="1800"/>
+            <a:endParaRPr sz="2100"/>
           </a:p>
           <a:p>
-            <a:pPr indent="-342900" lvl="0" marL="457200" rtl="0" algn="l">
-              <a:spcBef>
-                <a:spcPts val="0"/>
-              </a:spcBef>
-              <a:spcAft>
-                <a:spcPts val="0"/>
-              </a:spcAft>
-              <a:buSzPts val="1800"/>
+            <a:pPr indent="-514350" lvl="0" marL="609600" rtl="0" algn="l">
+              <a:spcBef>
+                <a:spcPts val="0"/>
+              </a:spcBef>
+              <a:spcAft>
+                <a:spcPts val="0"/>
+              </a:spcAft>
+              <a:buSzPts val="2100"/>
               <a:buChar char="●"/>
             </a:pPr>
             <a:r>
-              <a:rPr lang="en-US" sz="1800"/>
-              <a:t>Have an open and documented technical governance, including:</a:t>
+              <a:rPr lang="en-US" sz="2100"/>
+              <a:t>Have achieved and maintained an </a:t>
             </a:r>
-            <a:endParaRPr sz="1800"/>
+            <a:r>
+              <a:rPr lang="en-US" sz="2100" u="sng">
+                <a:solidFill>
+                  <a:schemeClr val="hlink"/>
+                </a:solidFill>
+                <a:hlinkClick r:id="rId3"/>
+              </a:rPr>
+              <a:t>OpenSSF Best Practices Badge</a:t>
+            </a:r>
+            <a:r>
+              <a:rPr lang="en-US" sz="2100"/>
+              <a:t> at the </a:t>
+            </a:r>
+            <a:r>
+              <a:rPr lang="en-US" sz="2100" u="sng">
+                <a:solidFill>
+                  <a:schemeClr val="hlink"/>
+                </a:solidFill>
+                <a:hlinkClick r:id="rId4"/>
+              </a:rPr>
+              <a:t>‘Passing’ level</a:t>
+            </a:r>
+            <a:r>
+              <a:rPr lang="en-US" sz="2100"/>
+              <a:t>.</a:t>
+            </a:r>
+            <a:endParaRPr sz="2100"/>
           </a:p>
           <a:p>
-            <a:pPr indent="-311150" lvl="1" marL="914400" rtl="0" algn="l">
-              <a:spcBef>
-                <a:spcPts val="0"/>
-              </a:spcBef>
-              <a:spcAft>
-                <a:spcPts val="0"/>
-              </a:spcAft>
-              <a:buSzPts val="1300"/>
+            <a:pPr indent="-514350" lvl="0" marL="609600" rtl="0" algn="l">
+              <a:spcBef>
+                <a:spcPts val="0"/>
+              </a:spcBef>
+              <a:spcAft>
+                <a:spcPts val="0"/>
+              </a:spcAft>
+              <a:buSzPts val="2100"/>
               <a:buChar char="●"/>
             </a:pPr>
             <a:r>
-              <a:rPr lang="en-US" sz="1300"/>
-              <a:t>A LICENSE file in every code repository, with the license chosen an </a:t>
+              <a:rPr lang="en-US" sz="2100"/>
+              <a:t>Have an open and documented technical governance, including:</a:t>
             </a:r>
-            <a:r>
-              <a:rPr lang="en-US" sz="1300" u="sng">
-                <a:solidFill>
-                  <a:schemeClr val="hlink"/>
-                </a:solidFill>
-                <a:hlinkClick r:id="rId3"/>
-              </a:rPr>
-              <a:t>OSI-approved license</a:t>
-            </a:r>
-            <a:r>
-              <a:rPr lang="en-US" sz="1300"/>
-              <a:t>.</a:t>
-            </a:r>
-            <a:endParaRPr sz="1300"/>
+            <a:endParaRPr sz="2100"/>
           </a:p>
           <a:p>
-            <a:pPr indent="-311150" lvl="1" marL="914400" rtl="0" algn="l">
-              <a:spcBef>
-                <a:spcPts val="0"/>
-              </a:spcBef>
-              <a:spcAft>
-                <a:spcPts val="0"/>
-              </a:spcAft>
-              <a:buSzPts val="1300"/>
+            <a:pPr indent="-635000" lvl="1" marL="1219200" rtl="0" algn="l">
+              <a:spcBef>
+                <a:spcPts val="0"/>
+              </a:spcBef>
+              <a:spcAft>
+                <a:spcPts val="0"/>
+              </a:spcAft>
+              <a:buSzPts val="1600"/>
               <a:buChar char="●"/>
             </a:pPr>
             <a:r>
-              <a:rPr lang="en-US" sz="1300"/>
-              <a:t>A README file welcoming new community members to the project and explaining why the project is useful and how to get started.</a:t>
+              <a:rPr lang="en-US" sz="1600"/>
+              <a:t>A README file in each code repository, welcoming new community members to the project and explaining why the project is useful and how to get started (follow the guidelines at the </a:t>
             </a:r>
-            <a:endParaRPr sz="1300"/>
+            <a:r>
+              <a:rPr lang="en-US" sz="1600" u="sng">
+                <a:solidFill>
+                  <a:schemeClr val="hlink"/>
+                </a:solidFill>
+                <a:hlinkClick r:id="rId5"/>
+              </a:rPr>
+              <a:t>README checklist</a:t>
+            </a:r>
+            <a:r>
+              <a:rPr lang="en-US" sz="1600"/>
+              <a:t> to create an excellent README file).</a:t>
+            </a:r>
+            <a:endParaRPr sz="1600"/>
           </a:p>
           <a:p>
-            <a:pPr indent="-311150" lvl="1" marL="914400" rtl="0" algn="l">
-              <a:spcBef>
-                <a:spcPts val="0"/>
-              </a:spcBef>
-              <a:spcAft>
-                <a:spcPts val="0"/>
-              </a:spcAft>
-              <a:buSzPts val="1300"/>
+            <a:pPr indent="-635000" lvl="1" marL="1219200" rtl="0" algn="l">
+              <a:spcBef>
+                <a:spcPts val="0"/>
+              </a:spcBef>
+              <a:spcAft>
+                <a:spcPts val="0"/>
+              </a:spcAft>
+              <a:buSzPts val="1600"/>
               <a:buChar char="●"/>
             </a:pPr>
             <a:r>
-              <a:rPr lang="en-US" sz="1300"/>
-              <a:t>A CONTRIBUTING file explaining to other developers and your community of users how to contribute to the project. The file should explain what types of contributions are needed and how the process works.</a:t>
+              <a:rPr lang="en-US" sz="1600"/>
+              <a:t>A GOVERNANCE file that documents the project’s technical governance (</a:t>
             </a:r>
-            <a:endParaRPr sz="1300"/>
+            <a:r>
+              <a:rPr lang="en-US" sz="1600" u="sng">
+                <a:solidFill>
+                  <a:schemeClr val="hlink"/>
+                </a:solidFill>
+                <a:hlinkClick r:id="rId6"/>
+              </a:rPr>
+              <a:t>template</a:t>
+            </a:r>
+            <a:r>
+              <a:rPr lang="en-US" sz="1600"/>
+              <a:t>).</a:t>
+            </a:r>
+            <a:endParaRPr sz="1600"/>
           </a:p>
           <a:p>
-            <a:pPr indent="-311150" lvl="1" marL="914400" rtl="0" algn="l">
-              <a:spcBef>
-                <a:spcPts val="0"/>
-              </a:spcBef>
-              <a:spcAft>
-                <a:spcPts val="0"/>
-              </a:spcAft>
-              <a:buSzPts val="1300"/>
+            <a:pPr indent="-635000" lvl="1" marL="1219200" rtl="0" algn="l">
+              <a:spcBef>
+                <a:spcPts val="0"/>
+              </a:spcBef>
+              <a:spcAft>
+                <a:spcPts val="0"/>
+              </a:spcAft>
+              <a:buSzPts val="1600"/>
               <a:buChar char="●"/>
             </a:pPr>
             <a:r>
-              <a:rPr lang="en-US" sz="1300"/>
-              <a:t>A CODEOWNERS or COMMITTERS file to define individuals or teams that are responsible for code in a repository; document current project owners and current and emeritus committers. </a:t>
+              <a:rPr lang="en-US" sz="1600"/>
+              <a:t>All current Technical Steering Committee members specified in the ‘Technical Steering Committee (TSC)’ committee in LFX Project Control Center (details on how this should be set up are </a:t>
             </a:r>
-            <a:endParaRPr sz="1300"/>
+            <a:r>
+              <a:rPr lang="en-US" sz="1600" u="sng">
+                <a:solidFill>
+                  <a:schemeClr val="hlink"/>
+                </a:solidFill>
+                <a:hlinkClick r:id="rId7"/>
+              </a:rPr>
+              <a:t>here</a:t>
+            </a:r>
+            <a:r>
+              <a:rPr lang="en-US" sz="1600"/>
+              <a:t>).</a:t>
+            </a:r>
+            <a:endParaRPr sz="1600"/>
           </a:p>
           <a:p>
-            <a:pPr indent="-311150" lvl="1" marL="914400" rtl="0" algn="l">
-              <a:spcBef>
-                <a:spcPts val="0"/>
-              </a:spcBef>
-              <a:spcAft>
-                <a:spcPts val="0"/>
-              </a:spcAft>
-              <a:buSzPts val="1300"/>
+            <a:pPr indent="-635000" lvl="1" marL="1219200" rtl="0" algn="l">
+              <a:spcBef>
+                <a:spcPts val="0"/>
+              </a:spcBef>
+              <a:spcAft>
+                <a:spcPts val="0"/>
+              </a:spcAft>
+              <a:buSzPts val="1600"/>
               <a:buChar char="●"/>
             </a:pPr>
             <a:r>
-              <a:rPr lang="en-US" sz="1300"/>
-              <a:t>A CODE_OF_CONDUCT file that sets the ground rules for participants’ behavior associated and helps to facilitate a friendly, welcoming environment. By default projects should leverage the </a:t>
+              <a:rPr lang="en-US" sz="1600"/>
+              <a:t>A CODEOWNERS or COMMITTERS file to define individuals or teams that are responsible for code in a repository, as well as documenting current project owners and current and emeritus committers ( </a:t>
             </a:r>
             <a:r>
-              <a:rPr lang="en-US" sz="1300" u="sng">
+              <a:rPr lang="en-US" sz="1600" u="sng">
                 <a:solidFill>
                   <a:schemeClr val="hlink"/>
                 </a:solidFill>
-                <a:hlinkClick r:id="rId4"/>
+                <a:hlinkClick r:id="rId8"/>
               </a:rPr>
-              <a:t>Linux Foundation Code of Conduct</a:t>
+              <a:t>template</a:t>
             </a:r>
             <a:r>
-              <a:rPr lang="en-US" sz="1300"/>
-              <a:t> unless an alternate Code of Conduct is approved prior.</a:t>
+              <a:rPr lang="en-US" sz="1600"/>
+              <a:t> )</a:t>
             </a:r>
-            <a:endParaRPr sz="1300"/>
-          </a:p>
-          <a:p>
-            <a:pPr indent="-311150" lvl="1" marL="914400" rtl="0" algn="l">
-              <a:spcBef>
-                <a:spcPts val="0"/>
-              </a:spcBef>
-              <a:spcAft>
-                <a:spcPts val="0"/>
-              </a:spcAft>
-              <a:buSzPts val="1300"/>
-              <a:buChar char="●"/>
-            </a:pPr>
-            <a:r>
-              <a:rPr lang="en-US" sz="1300"/>
-              <a:t>A RELEASE file that provides documentation on the release methodology, cadence, criteria, etc.</a:t>
-            </a:r>
-            <a:endParaRPr sz="1300"/>
-          </a:p>
-          <a:p>
-            <a:pPr indent="-311150" lvl="1" marL="914400" rtl="0" algn="l">
-              <a:spcBef>
-                <a:spcPts val="0"/>
-              </a:spcBef>
-              <a:spcAft>
-                <a:spcPts val="0"/>
-              </a:spcAft>
-              <a:buSzPts val="1300"/>
-              <a:buChar char="●"/>
-            </a:pPr>
-            <a:r>
-              <a:rPr lang="en-US" sz="1300"/>
-              <a:t>A GOVERNANCE file that documents the project’s technical governance.</a:t>
-            </a:r>
-            <a:endParaRPr sz="1300"/>
-          </a:p>
-          <a:p>
-            <a:pPr indent="-311150" lvl="1" marL="914400" rtl="0" algn="l">
-              <a:spcBef>
-                <a:spcPts val="0"/>
-              </a:spcBef>
-              <a:spcAft>
-                <a:spcPts val="0"/>
-              </a:spcAft>
-              <a:buSzPts val="1300"/>
-              <a:buChar char="●"/>
-            </a:pPr>
-            <a:r>
-              <a:rPr lang="en-US" sz="1300"/>
-              <a:t>A SUPPORT file to let users and developers know about ways to get help with your project.</a:t>
-            </a:r>
-            <a:endParaRPr sz="1300"/>
-          </a:p>
-          <a:p>
-            <a:pPr indent="-342900" lvl="0" marL="457200" rtl="0" algn="l">
-              <a:spcBef>
-                <a:spcPts val="0"/>
-              </a:spcBef>
-              <a:spcAft>
-                <a:spcPts val="0"/>
-              </a:spcAft>
-              <a:buSzPts val="1800"/>
-              <a:buChar char="●"/>
-            </a:pPr>
-            <a:r>
-              <a:rPr lang="en-US" sz="1800"/>
-              <a:t>Complete and approve the Technical Charter and agree to transfer any relevant trademarks to The Linux Foundation or its affiliate, LF Projects, LLC, and to assist in filing for any relevant unregistered ones.</a:t>
-            </a:r>
-            <a:endParaRPr sz="1800"/>
+            <a:endParaRPr sz="2100"/>
           </a:p>
         </p:txBody>
       </p:sp>
@@ -20676,293 +20660,149 @@
           </a:bodyPr>
           <a:lstStyle/>
           <a:p>
-            <a:pPr indent="-342900" lvl="0" marL="457200" rtl="0" algn="l">
-              <a:spcBef>
-                <a:spcPts val="0"/>
-              </a:spcBef>
-              <a:spcAft>
-                <a:spcPts val="0"/>
-              </a:spcAft>
-              <a:buSzPts val="1800"/>
+            <a:pPr indent="-508000" lvl="0" marL="609600" rtl="0" algn="l">
+              <a:spcBef>
+                <a:spcPts val="0"/>
+              </a:spcBef>
+              <a:spcAft>
+                <a:spcPts val="0"/>
+              </a:spcAft>
+              <a:buSzPts val="2000"/>
               <a:buChar char="●"/>
             </a:pPr>
             <a:r>
-              <a:rPr lang="en-US" sz="1800"/>
-              <a:t>Have achieved and maintained an </a:t>
+              <a:rPr lang="en-US" sz="2000"/>
+              <a:t>Documentation of the architecture (aka high-level design) of the software produced by the project (</a:t>
             </a:r>
             <a:r>
-              <a:rPr lang="en-US" sz="1800" u="sng">
-                <a:solidFill>
-                  <a:schemeClr val="accent5"/>
-                </a:solidFill>
-                <a:hlinkClick r:id="rId3">
-                  <a:extLst>
-                    <a:ext uri="{A12FA001-AC4F-418D-AE19-62706E023703}">
-                      <ahyp:hlinkClr val="tx"/>
-                    </a:ext>
-                  </a:extLst>
-                </a:hlinkClick>
+              <a:rPr lang="en-US" sz="2000" u="sng">
+                <a:solidFill>
+                  <a:schemeClr val="hlink"/>
+                </a:solidFill>
+                <a:hlinkClick r:id="rId3"/>
               </a:rPr>
-              <a:t>OpenSSF Best Practices Badge</a:t>
+              <a:t>aligns with this OpenSSF Best Practices Silver badge requirement</a:t>
             </a:r>
             <a:r>
-              <a:rPr lang="en-US" sz="1800"/>
-              <a:t> at the </a:t>
+              <a:rPr lang="en-US" sz="2000"/>
+              <a:t>).</a:t>
             </a:r>
-            <a:r>
-              <a:rPr lang="en-US" sz="1800" u="sng">
-                <a:solidFill>
-                  <a:schemeClr val="accent5"/>
-                </a:solidFill>
-                <a:hlinkClick r:id="rId4">
-                  <a:extLst>
-                    <a:ext uri="{A12FA001-AC4F-418D-AE19-62706E023703}">
-                      <ahyp:hlinkClr val="tx"/>
-                    </a:ext>
-                  </a:extLst>
-                </a:hlinkClick>
-              </a:rPr>
-              <a:t>‘Passing' level</a:t>
-            </a:r>
-            <a:r>
-              <a:rPr lang="en-US" sz="1800"/>
-              <a:t>.</a:t>
-            </a:r>
-            <a:endParaRPr sz="1800"/>
+            <a:endParaRPr sz="2000"/>
           </a:p>
           <a:p>
-            <a:pPr indent="-342900" lvl="0" marL="457200" rtl="0" algn="l">
-              <a:spcBef>
-                <a:spcPts val="0"/>
-              </a:spcBef>
-              <a:spcAft>
-                <a:spcPts val="0"/>
-              </a:spcAft>
-              <a:buSzPts val="1800"/>
+            <a:pPr indent="-508000" lvl="0" marL="609600" rtl="0" algn="l">
+              <a:spcBef>
+                <a:spcPts val="0"/>
+              </a:spcBef>
+              <a:spcAft>
+                <a:spcPts val="0"/>
+              </a:spcAft>
+              <a:buSzPts val="2000"/>
               <a:buChar char="●"/>
             </a:pPr>
             <a:r>
-              <a:rPr lang="en-US" sz="1800"/>
-              <a:t>Have had a successful license scan with any critical issues remedied.</a:t>
+              <a:rPr lang="en-US" sz="2000"/>
+              <a:t>A documented roadmap that describes what the project intends to do and not do for at least the next year (</a:t>
             </a:r>
-            <a:endParaRPr sz="1800"/>
+            <a:r>
+              <a:rPr lang="en-US" sz="2000" u="sng">
+                <a:solidFill>
+                  <a:schemeClr val="hlink"/>
+                </a:solidFill>
+                <a:hlinkClick r:id="rId4"/>
+              </a:rPr>
+              <a:t>aligns with this OpenSSF Best Practices Silver badge requirement</a:t>
+            </a:r>
+            <a:r>
+              <a:rPr lang="en-US" sz="2000"/>
+              <a:t>).</a:t>
+            </a:r>
+            <a:endParaRPr sz="2000"/>
           </a:p>
           <a:p>
-            <a:pPr indent="-342900" lvl="0" marL="457200" rtl="0" algn="l">
-              <a:spcBef>
-                <a:spcPts val="0"/>
-              </a:spcBef>
-              <a:spcAft>
-                <a:spcPts val="0"/>
-              </a:spcAft>
-              <a:buSzPts val="1800"/>
+            <a:pPr indent="-508000" lvl="0" marL="609600" rtl="0" algn="l">
+              <a:spcBef>
+                <a:spcPts val="0"/>
+              </a:spcBef>
+              <a:spcAft>
+                <a:spcPts val="0"/>
+              </a:spcAft>
+              <a:buSzPts val="2000"/>
               <a:buChar char="●"/>
             </a:pPr>
             <a:r>
-              <a:rPr lang="en-US" sz="1800"/>
-              <a:t>Have a defined project mission and scope</a:t>
+              <a:rPr lang="en-US" sz="2000"/>
+              <a:t>Community and contributor growth assessment using the data from LFX Insights. Specific metrics that will be reviewed are.</a:t>
             </a:r>
-            <a:endParaRPr sz="1800"/>
+            <a:endParaRPr sz="2000"/>
           </a:p>
           <a:p>
-            <a:pPr indent="-342900" lvl="0" marL="457200" rtl="0" algn="l">
-              <a:spcBef>
-                <a:spcPts val="0"/>
-              </a:spcBef>
-              <a:spcAft>
-                <a:spcPts val="0"/>
-              </a:spcAft>
-              <a:buSzPts val="1800"/>
+            <a:pPr indent="-628650" lvl="1" marL="1219200" rtl="0" algn="l">
+              <a:spcBef>
+                <a:spcPts val="0"/>
+              </a:spcBef>
+              <a:spcAft>
+                <a:spcPts val="0"/>
+              </a:spcAft>
+              <a:buSzPts val="1500"/>
               <a:buChar char="●"/>
             </a:pPr>
             <a:r>
-              <a:rPr lang="en-US" sz="1800"/>
-              <a:t>The project's functional architecture is built out in the </a:t>
+              <a:rPr lang="en-US" sz="1500"/>
+              <a:t>Current number of contributors, committers, and different organizations contributing to the project.</a:t>
             </a:r>
-            <a:r>
-              <a:rPr lang="en-US" sz="1800" u="sng">
-                <a:solidFill>
-                  <a:schemeClr val="hlink"/>
-                </a:solidFill>
-                <a:hlinkClick r:id="rId5"/>
-              </a:rPr>
-              <a:t>LF Energy ArchiMate tool</a:t>
-            </a:r>
-            <a:r>
-              <a:rPr lang="en-US" sz="1800"/>
-              <a:t>.</a:t>
-            </a:r>
-            <a:endParaRPr sz="1800"/>
+            <a:endParaRPr sz="1500"/>
           </a:p>
           <a:p>
-            <a:pPr indent="-342900" lvl="0" marL="457200" rtl="0" algn="l">
-              <a:spcBef>
-                <a:spcPts val="0"/>
-              </a:spcBef>
-              <a:spcAft>
-                <a:spcPts val="0"/>
-              </a:spcAft>
-              <a:buSzPts val="1800"/>
+            <a:pPr indent="-628650" lvl="1" marL="1219200" rtl="0" algn="l">
+              <a:spcBef>
+                <a:spcPts val="0"/>
+              </a:spcBef>
+              <a:spcAft>
+                <a:spcPts val="0"/>
+              </a:spcAft>
+              <a:buSzPts val="1500"/>
               <a:buChar char="●"/>
             </a:pPr>
             <a:r>
-              <a:rPr lang="en-US" sz="1800"/>
-              <a:t>An overview of the project’s architecture and features defined.</a:t>
+              <a:rPr lang="en-US" sz="1500"/>
+              <a:t>Flow of commits / merged contributions</a:t>
             </a:r>
-            <a:endParaRPr sz="1800"/>
+            <a:endParaRPr sz="1500"/>
           </a:p>
           <a:p>
-            <a:pPr indent="-342900" lvl="0" marL="457200" rtl="0" algn="l">
-              <a:spcBef>
-                <a:spcPts val="0"/>
-              </a:spcBef>
-              <a:spcAft>
-                <a:spcPts val="0"/>
-              </a:spcAft>
-              <a:buSzPts val="1800"/>
+            <a:pPr indent="-508000" lvl="0" marL="609600" rtl="0" algn="l">
+              <a:spcBef>
+                <a:spcPts val="0"/>
+              </a:spcBef>
+              <a:spcAft>
+                <a:spcPts val="0"/>
+              </a:spcAft>
+              <a:buSzPts val="2000"/>
               <a:buChar char="●"/>
             </a:pPr>
             <a:r>
-              <a:rPr lang="en-US" sz="1800"/>
-              <a:t>The project roadmap defined, which should address the following questions.</a:t>
+              <a:rPr lang="en-US" sz="2000"/>
+              <a:t>A credible plan for developing a thriving user community, particularly expanding the number of committers and contributors to the project.</a:t>
             </a:r>
-            <a:endParaRPr sz="1800"/>
+            <a:endParaRPr sz="2000"/>
           </a:p>
           <a:p>
-            <a:pPr indent="-311150" lvl="1" marL="914400" rtl="0" algn="l">
-              <a:spcBef>
-                <a:spcPts val="0"/>
-              </a:spcBef>
-              <a:spcAft>
-                <a:spcPts val="0"/>
-              </a:spcAft>
-              <a:buSzPts val="1300"/>
+            <a:pPr indent="-508000" lvl="0" marL="609600" rtl="0" algn="l">
+              <a:spcBef>
+                <a:spcPts val="0"/>
+              </a:spcBef>
+              <a:spcAft>
+                <a:spcPts val="0"/>
+              </a:spcAft>
+              <a:buSzPts val="2000"/>
               <a:buChar char="●"/>
             </a:pPr>
             <a:r>
-              <a:rPr lang="en-US" sz="1300"/>
-              <a:t>What use cases are possible now?</a:t>
+              <a:rPr lang="en-US" sz="2000"/>
+              <a:t>An outline of the plan for the project to complete the requirements for the Early Adoption stage.</a:t>
             </a:r>
-            <a:endParaRPr sz="1300"/>
-          </a:p>
-          <a:p>
-            <a:pPr indent="-311150" lvl="1" marL="914400" rtl="0" algn="l">
-              <a:spcBef>
-                <a:spcPts val="0"/>
-              </a:spcBef>
-              <a:spcAft>
-                <a:spcPts val="0"/>
-              </a:spcAft>
-              <a:buSzPts val="1300"/>
-              <a:buChar char="●"/>
-            </a:pPr>
-            <a:r>
-              <a:rPr lang="en-US" sz="1300"/>
-              <a:t>What does the next year look like in terms of additional features and use cases covered?</a:t>
-            </a:r>
-            <a:endParaRPr sz="1300"/>
-          </a:p>
-          <a:p>
-            <a:pPr indent="-342900" lvl="0" marL="457200" rtl="0" algn="l">
-              <a:spcBef>
-                <a:spcPts val="0"/>
-              </a:spcBef>
-              <a:spcAft>
-                <a:spcPts val="0"/>
-              </a:spcAft>
-              <a:buSzPts val="1800"/>
-              <a:buChar char="●"/>
-            </a:pPr>
-            <a:r>
-              <a:rPr lang="en-US" sz="1800"/>
-              <a:t>Community and contributor growth assessment</a:t>
-            </a:r>
-            <a:endParaRPr sz="1800"/>
-          </a:p>
-          <a:p>
-            <a:pPr indent="-311150" lvl="1" marL="914400" rtl="0" algn="l">
-              <a:spcBef>
-                <a:spcPts val="0"/>
-              </a:spcBef>
-              <a:spcAft>
-                <a:spcPts val="0"/>
-              </a:spcAft>
-              <a:buSzPts val="1300"/>
-              <a:buChar char="●"/>
-            </a:pPr>
-            <a:r>
-              <a:rPr lang="en-US" sz="1300"/>
-              <a:t>The current number of contributors and committers, and the number of different organizations contributing to the project.</a:t>
-            </a:r>
-            <a:endParaRPr sz="1300"/>
-          </a:p>
-          <a:p>
-            <a:pPr indent="-311150" lvl="1" marL="914400" rtl="0" algn="l">
-              <a:spcBef>
-                <a:spcPts val="0"/>
-              </a:spcBef>
-              <a:spcAft>
-                <a:spcPts val="0"/>
-              </a:spcAft>
-              <a:buSzPts val="1300"/>
-              <a:buChar char="●"/>
-            </a:pPr>
-            <a:r>
-              <a:rPr lang="en-US" sz="1300"/>
-              <a:t>Demonstrate a sustained flow of commits / merged contributions</a:t>
-            </a:r>
-            <a:endParaRPr sz="1300"/>
-          </a:p>
-          <a:p>
-            <a:pPr indent="-311150" lvl="1" marL="914400" rtl="0" algn="l">
-              <a:spcBef>
-                <a:spcPts val="0"/>
-              </a:spcBef>
-              <a:spcAft>
-                <a:spcPts val="0"/>
-              </a:spcAft>
-              <a:buSzPts val="1300"/>
-              <a:buChar char="●"/>
-            </a:pPr>
-            <a:r>
-              <a:rPr lang="en-US" sz="1300"/>
-              <a:t>A credible plan for developing a thriving user community, in particular expanding the number of committers and contributors?</a:t>
-            </a:r>
-            <a:endParaRPr sz="1300"/>
-          </a:p>
-          <a:p>
-            <a:pPr indent="-311150" lvl="1" marL="914400" rtl="0" algn="l">
-              <a:spcBef>
-                <a:spcPts val="0"/>
-              </a:spcBef>
-              <a:spcAft>
-                <a:spcPts val="0"/>
-              </a:spcAft>
-              <a:buSzPts val="1300"/>
-              <a:buChar char="●"/>
-            </a:pPr>
-            <a:r>
-              <a:rPr lang="en-US" sz="1300"/>
-              <a:t>An outline of the plan for the project to complete the requirements for the Early Adoption stage</a:t>
-            </a:r>
-            <a:endParaRPr sz="1300"/>
-          </a:p>
-          <a:p>
-            <a:pPr indent="-342900" lvl="0" marL="457200" rtl="0" algn="l">
-              <a:spcBef>
-                <a:spcPts val="0"/>
-              </a:spcBef>
-              <a:spcAft>
-                <a:spcPts val="0"/>
-              </a:spcAft>
-              <a:buSzPts val="1800"/>
-              <a:buChar char="●"/>
-            </a:pPr>
-            <a:r>
-              <a:rPr lang="en-US" sz="1800"/>
-              <a:t>Receive the affirmative majority vote of the TAC.</a:t>
-            </a:r>
-            <a:endParaRPr sz="1800"/>
+            <a:endParaRPr sz="2000"/>
           </a:p>
         </p:txBody>
       </p:sp>
@@ -21160,7 +21000,7 @@
         </p:spPr>
         <p:txBody>
           <a:bodyPr anchorCtr="0" anchor="t" bIns="121900" lIns="121900" spcFirstLastPara="1" rIns="121900" wrap="square" tIns="121900">
-            <a:normAutofit/>
+            <a:normAutofit fontScale="62500" lnSpcReduction="20000"/>
           </a:bodyPr>
           <a:lstStyle/>
           <a:p>
@@ -21174,274 +21014,282 @@
               <a:buNone/>
             </a:pPr>
             <a:r>
-              <a:rPr lang="en-US" sz="1600"/>
+              <a:rPr lang="en-US"/>
               <a:t>To be considered for the Early Adoption stage, the project must meet the following requirements:</a:t>
             </a:r>
-            <a:endParaRPr sz="1600"/>
+            <a:endParaRPr/>
           </a:p>
           <a:p>
-            <a:pPr indent="-330200" lvl="0" marL="457200" rtl="0" algn="l">
-              <a:spcBef>
-                <a:spcPts val="0"/>
-              </a:spcBef>
-              <a:spcAft>
-                <a:spcPts val="0"/>
-              </a:spcAft>
-              <a:buSzPts val="1600"/>
+            <a:pPr indent="0" lvl="0" marL="0" rtl="0" algn="l">
+              <a:spcBef>
+                <a:spcPts val="0"/>
+              </a:spcBef>
+              <a:spcAft>
+                <a:spcPts val="0"/>
+              </a:spcAft>
+              <a:buNone/>
+            </a:pPr>
+            <a:r>
+              <a:t/>
+            </a:r>
+            <a:endParaRPr/>
+          </a:p>
+          <a:p>
+            <a:pPr indent="-323850" lvl="0" marL="457200" rtl="0" algn="l">
+              <a:spcBef>
+                <a:spcPts val="0"/>
+              </a:spcBef>
+              <a:spcAft>
+                <a:spcPts val="0"/>
+              </a:spcAft>
+              <a:buSzPct val="100000"/>
               <a:buChar char="●"/>
             </a:pPr>
             <a:r>
-              <a:rPr lang="en-US" sz="1600"/>
+              <a:rPr lang="en-US"/>
               <a:t>Demonstrate growth in the project’s community, including</a:t>
             </a:r>
-            <a:endParaRPr sz="1600"/>
+            <a:endParaRPr/>
           </a:p>
           <a:p>
-            <a:pPr indent="-298450" lvl="1" marL="914400" rtl="0" algn="l">
-              <a:spcBef>
-                <a:spcPts val="0"/>
-              </a:spcBef>
-              <a:spcAft>
-                <a:spcPts val="0"/>
-              </a:spcAft>
-              <a:buSzPts val="1100"/>
+            <a:pPr indent="-304006" lvl="1" marL="914400" rtl="0" algn="l">
+              <a:spcBef>
+                <a:spcPts val="0"/>
+              </a:spcBef>
+              <a:spcAft>
+                <a:spcPts val="0"/>
+              </a:spcAft>
+              <a:buSzPct val="100000"/>
+              <a:buChar char="○"/>
+            </a:pPr>
+            <a:r>
+              <a:rPr lang="en-US"/>
+              <a:t>Growth in the number of commits to the project, the number of project committers, and the organizational diversity of contributions and committers.</a:t>
+            </a:r>
+            <a:endParaRPr/>
+          </a:p>
+          <a:p>
+            <a:pPr indent="-304006" lvl="1" marL="914400" rtl="0" algn="l">
+              <a:spcBef>
+                <a:spcPts val="0"/>
+              </a:spcBef>
+              <a:spcAft>
+                <a:spcPts val="0"/>
+              </a:spcAft>
+              <a:buSzPct val="100000"/>
+              <a:buChar char="○"/>
+            </a:pPr>
+            <a:r>
+              <a:rPr lang="en-US"/>
+              <a:t>Production or planned production use of the project by at least two independent end users, which, in the TAC’s judgment, are of adequate quality and scope.</a:t>
+            </a:r>
+            <a:endParaRPr/>
+          </a:p>
+          <a:p>
+            <a:pPr indent="-323850" lvl="0" marL="457200" rtl="0" algn="l">
+              <a:spcBef>
+                <a:spcPts val="0"/>
+              </a:spcBef>
+              <a:spcAft>
+                <a:spcPts val="0"/>
+              </a:spcAft>
+              <a:buSzPct val="100000"/>
               <a:buChar char="●"/>
             </a:pPr>
             <a:r>
-              <a:rPr lang="en-US" sz="1100"/>
-              <a:t>Growth in the number of commits to the project, number of project committers, and organizational diversity of contributions and committers.</a:t>
+              <a:rPr lang="en-US"/>
+              <a:t>Technical Governance of the project is operational, as measured by:</a:t>
             </a:r>
-            <a:endParaRPr sz="1100"/>
+            <a:endParaRPr/>
           </a:p>
           <a:p>
-            <a:pPr indent="-298450" lvl="1" marL="914400" rtl="0" algn="l">
-              <a:spcBef>
-                <a:spcPts val="0"/>
-              </a:spcBef>
-              <a:spcAft>
-                <a:spcPts val="0"/>
-              </a:spcAft>
-              <a:buSzPts val="1100"/>
+            <a:pPr indent="-304006" lvl="1" marL="914400" rtl="0" algn="l">
+              <a:spcBef>
+                <a:spcPts val="0"/>
+              </a:spcBef>
+              <a:spcAft>
+                <a:spcPts val="0"/>
+              </a:spcAft>
+              <a:buSzPct val="100000"/>
+              <a:buChar char="○"/>
+            </a:pPr>
+            <a:r>
+              <a:rPr lang="en-US"/>
+              <a:t>A Technical Steering Committee with at least five members and a chairperson elected by the members, holding regular open meetings (</a:t>
+            </a:r>
+            <a:r>
+              <a:rPr lang="en-US" u="sng">
+                <a:solidFill>
+                  <a:schemeClr val="hlink"/>
+                </a:solidFill>
+                <a:hlinkClick r:id="rId3"/>
+              </a:rPr>
+              <a:t>aligns with OpenSSF Best Practices Gold badge requirement</a:t>
+            </a:r>
+            <a:r>
+              <a:rPr lang="en-US"/>
+              <a:t>)</a:t>
+            </a:r>
+            <a:endParaRPr/>
+          </a:p>
+          <a:p>
+            <a:pPr indent="-304006" lvl="1" marL="914400" rtl="0" algn="l">
+              <a:spcBef>
+                <a:spcPts val="0"/>
+              </a:spcBef>
+              <a:spcAft>
+                <a:spcPts val="0"/>
+              </a:spcAft>
+              <a:buSzPct val="100000"/>
+              <a:buChar char="○"/>
+            </a:pPr>
+            <a:r>
+              <a:rPr lang="en-US"/>
+              <a:t>Achievement of the OpenSSF Best Practice badge at the </a:t>
+            </a:r>
+            <a:r>
+              <a:rPr lang="en-US" u="sng">
+                <a:solidFill>
+                  <a:schemeClr val="hlink"/>
+                </a:solidFill>
+                <a:hlinkClick r:id="rId4"/>
+              </a:rPr>
+              <a:t>‘Silver’ Level</a:t>
+            </a:r>
+            <a:endParaRPr/>
+          </a:p>
+          <a:p>
+            <a:pPr indent="-323850" lvl="0" marL="457200" rtl="0" algn="l">
+              <a:spcBef>
+                <a:spcPts val="0"/>
+              </a:spcBef>
+              <a:spcAft>
+                <a:spcPts val="0"/>
+              </a:spcAft>
+              <a:buSzPct val="100000"/>
               <a:buChar char="●"/>
             </a:pPr>
             <a:r>
-              <a:rPr lang="en-US" sz="1100"/>
-              <a:t>Production or planned production use of the project by at least two independent end users which, in the TAC’s judgment, are of adequate quality and scope.</a:t>
+              <a:rPr lang="en-US"/>
+              <a:t>Development of a growth plan, to be done in conjunction with their project mentor(s) at the TAC. This plan should address the following points:</a:t>
             </a:r>
-            <a:endParaRPr sz="1100"/>
+            <a:endParaRPr/>
           </a:p>
           <a:p>
-            <a:pPr indent="-330200" lvl="0" marL="457200" rtl="0" algn="l">
-              <a:spcBef>
-                <a:spcPts val="0"/>
-              </a:spcBef>
-              <a:spcAft>
-                <a:spcPts val="0"/>
-              </a:spcAft>
-              <a:buSzPts val="1600"/>
-              <a:buChar char="●"/>
+            <a:pPr indent="-304006" lvl="1" marL="914400" rtl="0" algn="l">
+              <a:spcBef>
+                <a:spcPts val="0"/>
+              </a:spcBef>
+              <a:spcAft>
+                <a:spcPts val="0"/>
+              </a:spcAft>
+              <a:buSzPct val="100000"/>
+              <a:buChar char="○"/>
             </a:pPr>
             <a:r>
-              <a:rPr lang="en-US" sz="1600"/>
-              <a:t>Technical Governance of the project is operational, as measured by:</a:t>
+              <a:rPr lang="en-US"/>
+              <a:t>Release plans for the next 18 months.</a:t>
             </a:r>
-            <a:endParaRPr sz="1600"/>
+            <a:endParaRPr/>
           </a:p>
           <a:p>
-            <a:pPr indent="-298450" lvl="1" marL="914400" rtl="0" algn="l">
-              <a:spcBef>
-                <a:spcPts val="0"/>
-              </a:spcBef>
-              <a:spcAft>
-                <a:spcPts val="0"/>
-              </a:spcAft>
-              <a:buSzPts val="1100"/>
-              <a:buChar char="●"/>
+            <a:pPr indent="-304006" lvl="1" marL="914400" rtl="0" algn="l">
+              <a:spcBef>
+                <a:spcPts val="0"/>
+              </a:spcBef>
+              <a:spcAft>
+                <a:spcPts val="0"/>
+              </a:spcAft>
+              <a:buSzPct val="100000"/>
+              <a:buChar char="○"/>
             </a:pPr>
             <a:r>
-              <a:rPr lang="en-US" sz="1100"/>
-              <a:t>A Technical Steering Committee with at least 5 members and a chairperson elected by the members, holding regular open meetings.</a:t>
+              <a:rPr lang="en-US"/>
+              <a:t>Target end-users.</a:t>
             </a:r>
-            <a:endParaRPr sz="1100"/>
+            <a:endParaRPr/>
           </a:p>
           <a:p>
-            <a:pPr indent="-298450" lvl="1" marL="914400" rtl="0" algn="l">
-              <a:spcBef>
-                <a:spcPts val="0"/>
-              </a:spcBef>
-              <a:spcAft>
-                <a:spcPts val="0"/>
-              </a:spcAft>
-              <a:buSzPts val="1100"/>
-              <a:buChar char="●"/>
+            <a:pPr indent="-304006" lvl="1" marL="914400" rtl="0" algn="l">
+              <a:spcBef>
+                <a:spcPts val="0"/>
+              </a:spcBef>
+              <a:spcAft>
+                <a:spcPts val="0"/>
+              </a:spcAft>
+              <a:buSzPct val="100000"/>
+              <a:buChar char="○"/>
             </a:pPr>
             <a:r>
-              <a:rPr lang="en-US" sz="1100"/>
-              <a:t>Achievement of the OpenSSF Best Practice badge at the </a:t>
+              <a:rPr lang="en-US"/>
+              <a:t>Identification of any regulatory or standards body requirements for deployment and implementation plans.</a:t>
             </a:r>
-            <a:r>
-              <a:rPr lang="en-US" sz="1100" u="sng">
-                <a:solidFill>
-                  <a:schemeClr val="hlink"/>
-                </a:solidFill>
-                <a:hlinkClick r:id="rId3"/>
-              </a:rPr>
-              <a:t>'Silver' Level</a:t>
-            </a:r>
-            <a:endParaRPr sz="1100"/>
+            <a:endParaRPr/>
           </a:p>
           <a:p>
-            <a:pPr indent="-330200" lvl="0" marL="457200" rtl="0" algn="l">
-              <a:spcBef>
-                <a:spcPts val="0"/>
-              </a:spcBef>
-              <a:spcAft>
-                <a:spcPts val="0"/>
-              </a:spcAft>
-              <a:buSzPts val="1600"/>
-              <a:buChar char="●"/>
+            <a:pPr indent="-304006" lvl="1" marL="914400" rtl="0" algn="l">
+              <a:spcBef>
+                <a:spcPts val="0"/>
+              </a:spcBef>
+              <a:spcAft>
+                <a:spcPts val="0"/>
+              </a:spcAft>
+              <a:buSzPct val="100000"/>
+              <a:buChar char="○"/>
             </a:pPr>
             <a:r>
-              <a:rPr lang="en-US" sz="1600"/>
-              <a:t>Development of a growth plan, to be done in conjunction with their project mentor(s) at the TAC. This plan should address the following points:</a:t>
+              <a:rPr lang="en-US"/>
+              <a:t>Plans for the growth of project contributors and committers to support the growth plan.</a:t>
             </a:r>
-            <a:endParaRPr sz="1600"/>
+            <a:endParaRPr/>
           </a:p>
           <a:p>
-            <a:pPr indent="-298450" lvl="1" marL="914400" rtl="0" algn="l">
-              <a:spcBef>
-                <a:spcPts val="0"/>
-              </a:spcBef>
-              <a:spcAft>
-                <a:spcPts val="0"/>
-              </a:spcAft>
-              <a:buSzPts val="1100"/>
-              <a:buChar char="●"/>
+            <a:pPr indent="-304006" lvl="1" marL="914400" rtl="0" algn="l">
+              <a:spcBef>
+                <a:spcPts val="0"/>
+              </a:spcBef>
+              <a:spcAft>
+                <a:spcPts val="0"/>
+              </a:spcAft>
+              <a:buSzPct val="100000"/>
+              <a:buChar char="○"/>
             </a:pPr>
             <a:r>
-              <a:rPr lang="en-US" sz="1100"/>
+              <a:rPr lang="en-US"/>
+              <a:t>Identification of any infrastructure resources needed to fulfill the growth plan.</a:t>
+            </a:r>
+            <a:endParaRPr/>
+          </a:p>
+          <a:p>
+            <a:pPr indent="0" lvl="0" marL="0" rtl="0" algn="l">
+              <a:spcBef>
+                <a:spcPts val="0"/>
+              </a:spcBef>
+              <a:spcAft>
+                <a:spcPts val="0"/>
+              </a:spcAft>
+              <a:buNone/>
+            </a:pPr>
+            <a:r>
+              <a:t/>
+            </a:r>
+            <a:endParaRPr/>
+          </a:p>
+          <a:p>
+            <a:pPr indent="0" lvl="0" marL="0" rtl="0" algn="l">
+              <a:spcBef>
+                <a:spcPts val="0"/>
+              </a:spcBef>
+              <a:spcAft>
+                <a:spcPts val="0"/>
+              </a:spcAft>
+              <a:buNone/>
+            </a:pPr>
+            <a:r>
+              <a:rPr lang="en-US"/>
               <a:t>Since these metrics can vary significantly depending on the type, scope, and size of a project, the TAC has final judgment over the level of activity that is adequate to meet these criteria.</a:t>
             </a:r>
-            <a:endParaRPr sz="1100"/>
-          </a:p>
-          <a:p>
-            <a:pPr indent="-298450" lvl="1" marL="914400" rtl="0" algn="l">
-              <a:spcBef>
-                <a:spcPts val="0"/>
-              </a:spcBef>
-              <a:spcAft>
-                <a:spcPts val="0"/>
-              </a:spcAft>
-              <a:buSzPts val="1100"/>
-              <a:buChar char="●"/>
-            </a:pPr>
-            <a:r>
-              <a:rPr lang="en-US" sz="1100"/>
-              <a:t>Release plans for the next 18 months.</a:t>
-            </a:r>
-            <a:endParaRPr sz="1100"/>
-          </a:p>
-          <a:p>
-            <a:pPr indent="-298450" lvl="1" marL="914400" rtl="0" algn="l">
-              <a:spcBef>
-                <a:spcPts val="0"/>
-              </a:spcBef>
-              <a:spcAft>
-                <a:spcPts val="0"/>
-              </a:spcAft>
-              <a:buSzPts val="1100"/>
-              <a:buChar char="●"/>
-            </a:pPr>
-            <a:r>
-              <a:rPr lang="en-US" sz="1100"/>
-              <a:t>Target end-users.</a:t>
-            </a:r>
-            <a:endParaRPr sz="1100"/>
-          </a:p>
-          <a:p>
-            <a:pPr indent="-298450" lvl="1" marL="914400" rtl="0" algn="l">
-              <a:spcBef>
-                <a:spcPts val="0"/>
-              </a:spcBef>
-              <a:spcAft>
-                <a:spcPts val="0"/>
-              </a:spcAft>
-              <a:buSzPts val="1100"/>
-              <a:buChar char="●"/>
-            </a:pPr>
-            <a:r>
-              <a:rPr lang="en-US" sz="1100"/>
-              <a:t>Identification of any regulatory or standards body requirements for deployment, and plans for implementation.</a:t>
-            </a:r>
-            <a:endParaRPr sz="1100"/>
-          </a:p>
-          <a:p>
-            <a:pPr indent="-298450" lvl="1" marL="914400" rtl="0" algn="l">
-              <a:spcBef>
-                <a:spcPts val="0"/>
-              </a:spcBef>
-              <a:spcAft>
-                <a:spcPts val="0"/>
-              </a:spcAft>
-              <a:buSzPts val="1100"/>
-              <a:buChar char="●"/>
-            </a:pPr>
-            <a:r>
-              <a:rPr lang="en-US" sz="1100"/>
-              <a:t>Plans for growth of project contributors and committers to support the growth plan.</a:t>
-            </a:r>
-            <a:endParaRPr sz="1100"/>
-          </a:p>
-          <a:p>
-            <a:pPr indent="-298450" lvl="1" marL="914400" rtl="0" algn="l">
-              <a:spcBef>
-                <a:spcPts val="0"/>
-              </a:spcBef>
-              <a:spcAft>
-                <a:spcPts val="0"/>
-              </a:spcAft>
-              <a:buSzPts val="1100"/>
-              <a:buChar char="●"/>
-            </a:pPr>
-            <a:r>
-              <a:rPr lang="en-US" sz="1100"/>
-              <a:t>Identification of any infrastructure resources needed to fulfill the growth plan.</a:t>
-            </a:r>
-            <a:endParaRPr sz="1100"/>
-          </a:p>
-          <a:p>
-            <a:pPr indent="-330200" lvl="0" marL="457200" rtl="0" algn="l">
-              <a:spcBef>
-                <a:spcPts val="0"/>
-              </a:spcBef>
-              <a:spcAft>
-                <a:spcPts val="0"/>
-              </a:spcAft>
-              <a:buSzPts val="1600"/>
-              <a:buChar char="●"/>
-            </a:pPr>
-            <a:r>
-              <a:rPr lang="en-US" sz="1600"/>
-              <a:t>Presentation to the TAC of the project’s growth, technical governance, and growth plan.</a:t>
-            </a:r>
-            <a:endParaRPr sz="1600"/>
-          </a:p>
-          <a:p>
-            <a:pPr indent="-330200" lvl="0" marL="457200" rtl="0" algn="l">
-              <a:spcBef>
-                <a:spcPts val="0"/>
-              </a:spcBef>
-              <a:spcAft>
-                <a:spcPts val="0"/>
-              </a:spcAft>
-              <a:buSzPts val="1600"/>
-              <a:buChar char="●"/>
-            </a:pPr>
-            <a:r>
-              <a:rPr lang="en-US" sz="1600"/>
-              <a:t>Receive the affirmative majority vote of the TAC and Governing Board</a:t>
-            </a:r>
-            <a:endParaRPr sz="1600"/>
+            <a:endParaRPr/>
           </a:p>
         </p:txBody>
       </p:sp>
@@ -21653,155 +21501,91 @@
               <a:buNone/>
             </a:pPr>
             <a:r>
-              <a:rPr lang="en-US" sz="1500"/>
+              <a:rPr lang="en-US" sz="2200"/>
               <a:t>To graduate from Incubation or Early Adoption status, or for a new project to join with Graduated status, a project must meet the Early Adoption stage criteria plus:</a:t>
             </a:r>
-            <a:endParaRPr sz="1500"/>
+            <a:endParaRPr sz="2200"/>
           </a:p>
           <a:p>
-            <a:pPr indent="-323850" lvl="0" marL="457200" rtl="0" algn="l">
-              <a:spcBef>
-                <a:spcPts val="0"/>
-              </a:spcBef>
-              <a:spcAft>
-                <a:spcPts val="0"/>
-              </a:spcAft>
-              <a:buSzPts val="1500"/>
+            <a:pPr indent="-368300" lvl="0" marL="457200" rtl="0" algn="l">
+              <a:spcBef>
+                <a:spcPts val="0"/>
+              </a:spcBef>
+              <a:spcAft>
+                <a:spcPts val="0"/>
+              </a:spcAft>
+              <a:buSzPts val="2200"/>
               <a:buChar char="●"/>
             </a:pPr>
             <a:r>
-              <a:rPr lang="en-US" sz="1500"/>
-              <a:t>Have a defined governing body of at least 5 or more members (owners and core maintainers), of which no more than 1/3 is affiliated with the same employer. In the case there are 5 governing members, 2 may be from the same employer.</a:t>
+              <a:rPr lang="en-US" sz="2200"/>
+              <a:t>Achievement of the OpenSSF Best Practices badge at the </a:t>
             </a:r>
-            <a:endParaRPr sz="1500"/>
+            <a:r>
+              <a:rPr lang="en-US" sz="2200" u="sng">
+                <a:solidFill>
+                  <a:schemeClr val="hlink"/>
+                </a:solidFill>
+                <a:hlinkClick r:id="rId3"/>
+              </a:rPr>
+              <a:t>‘Gold’ level</a:t>
+            </a:r>
+            <a:r>
+              <a:rPr lang="en-US" sz="2200"/>
+              <a:t>.</a:t>
+            </a:r>
+            <a:endParaRPr sz="2200"/>
           </a:p>
           <a:p>
-            <a:pPr indent="-323850" lvl="0" marL="457200" rtl="0" algn="l">
-              <a:spcBef>
-                <a:spcPts val="0"/>
-              </a:spcBef>
-              <a:spcAft>
-                <a:spcPts val="0"/>
-              </a:spcAft>
-              <a:buSzPts val="1500"/>
+            <a:pPr indent="-368300" lvl="0" marL="457200" rtl="0" algn="l">
+              <a:spcBef>
+                <a:spcPts val="0"/>
+              </a:spcBef>
+              <a:spcAft>
+                <a:spcPts val="0"/>
+              </a:spcAft>
+              <a:buSzPts val="2200"/>
               <a:buChar char="●"/>
             </a:pPr>
             <a:r>
-              <a:rPr lang="en-US" sz="1500"/>
+              <a:rPr lang="en-US" sz="2200"/>
               <a:t>Have fulfilled or are on track to complete the growth plan defined in the Early Adoption stage proposal.</a:t>
             </a:r>
-            <a:endParaRPr sz="1500"/>
+            <a:endParaRPr sz="2200"/>
           </a:p>
           <a:p>
-            <a:pPr indent="-323850" lvl="0" marL="457200" rtl="0" algn="l">
-              <a:spcBef>
-                <a:spcPts val="0"/>
-              </a:spcBef>
-              <a:spcAft>
-                <a:spcPts val="0"/>
-              </a:spcAft>
-              <a:buSzPts val="1500"/>
+            <a:pPr indent="-368300" lvl="0" marL="457200" rtl="0" algn="l">
+              <a:spcBef>
+                <a:spcPts val="0"/>
+              </a:spcBef>
+              <a:spcAft>
+                <a:spcPts val="0"/>
+              </a:spcAft>
+              <a:buSzPts val="2200"/>
               <a:buChar char="●"/>
             </a:pPr>
             <a:r>
-              <a:rPr lang="en-US" sz="1500"/>
+              <a:rPr lang="en-US" sz="2200"/>
               <a:t>Have a healthy number of contributions or committers from at least three organizations, with any single organization not composing more than 50% of the contributions or committers. Committers must be identified within the project in a COMMITTERS file.</a:t>
             </a:r>
-            <a:endParaRPr sz="1500"/>
+            <a:endParaRPr sz="2200"/>
           </a:p>
           <a:p>
-            <a:pPr indent="-323850" lvl="0" marL="457200" rtl="0" algn="l">
-              <a:spcBef>
-                <a:spcPts val="0"/>
-              </a:spcBef>
-              <a:spcAft>
-                <a:spcPts val="0"/>
-              </a:spcAft>
-              <a:buSzPts val="1500"/>
+            <a:pPr indent="-368300" lvl="0" marL="457200" rtl="0" algn="l">
+              <a:spcBef>
+                <a:spcPts val="0"/>
+              </a:spcBef>
+              <a:spcAft>
+                <a:spcPts val="0"/>
+              </a:spcAft>
+              <a:buSzPts val="2200"/>
               <a:buChar char="●"/>
             </a:pPr>
             <a:r>
-              <a:rPr lang="en-US" sz="1500"/>
-              <a:t>Have a public list of project adopters for at least the primary repo (e.g., </a:t>
+              <a:rPr lang="en-US" sz="2200"/>
+              <a:t>Have a public list of project adopters for at least the primary repo (e.g., ADOPTERS.md or logos on the project website).</a:t>
             </a:r>
-            <a:r>
-              <a:rPr lang="en-US" sz="1500" u="sng">
-                <a:solidFill>
-                  <a:schemeClr val="hlink"/>
-                </a:solidFill>
-                <a:hlinkClick r:id="rId3"/>
-              </a:rPr>
-              <a:t>ADOPTERS.md</a:t>
-            </a:r>
-            <a:r>
-              <a:rPr lang="en-US" sz="1500"/>
-              <a:t> or logos on the project website).</a:t>
-            </a:r>
-            <a:endParaRPr sz="1500"/>
-          </a:p>
-          <a:p>
-            <a:pPr indent="-323850" lvl="0" marL="457200" rtl="0" algn="l">
-              <a:spcBef>
-                <a:spcPts val="0"/>
-              </a:spcBef>
-              <a:spcAft>
-                <a:spcPts val="0"/>
-              </a:spcAft>
-              <a:buSzPts val="1500"/>
-              <a:buChar char="●"/>
-            </a:pPr>
-            <a:r>
-              <a:rPr lang="en-US" sz="1500"/>
-              <a:t>Achievement of the OpenSSF Best Practices badge at the </a:t>
-            </a:r>
-            <a:r>
-              <a:rPr lang="en-US" sz="1500" u="sng">
-                <a:solidFill>
-                  <a:schemeClr val="hlink"/>
-                </a:solidFill>
-                <a:hlinkClick r:id="rId4"/>
-              </a:rPr>
-              <a:t>'Gold' level</a:t>
-            </a:r>
-            <a:r>
-              <a:rPr lang="en-US" sz="1500"/>
-              <a:t>.</a:t>
-            </a:r>
-            <a:endParaRPr sz="1500"/>
-          </a:p>
-          <a:p>
-            <a:pPr indent="-323850" lvl="0" marL="457200" rtl="0" algn="l">
-              <a:spcBef>
-                <a:spcPts val="0"/>
-              </a:spcBef>
-              <a:spcAft>
-                <a:spcPts val="0"/>
-              </a:spcAft>
-              <a:buSzPts val="1500"/>
-              <a:buChar char="●"/>
-            </a:pPr>
-            <a:r>
-              <a:rPr lang="en-US" sz="1500"/>
-              <a:t>Present to the TAC and the Governing Board on the fulfillment of these requirements.</a:t>
-            </a:r>
-            <a:endParaRPr sz="1500"/>
-          </a:p>
-          <a:p>
-            <a:pPr indent="-323850" lvl="0" marL="457200" rtl="0" algn="l">
-              <a:spcBef>
-                <a:spcPts val="0"/>
-              </a:spcBef>
-              <a:spcAft>
-                <a:spcPts val="0"/>
-              </a:spcAft>
-              <a:buSzPts val="1500"/>
-              <a:buChar char="●"/>
-            </a:pPr>
-            <a:r>
-              <a:rPr lang="en-US" sz="1500"/>
-              <a:t>Receive a ⅔ majority vote from the TAC and a majority vote of the Governing Board to move to the Graduated stage. Projects can move directly from Incubation to Graduated status if they can demonstrate sufficient maturity and have met all requirements.</a:t>
-            </a:r>
-            <a:endParaRPr sz="1500"/>
+            <a:endParaRPr sz="2200"/>
           </a:p>
         </p:txBody>
       </p:sp>

</xml_diff>